<commit_message>
Update the submission deck with the track and add the track to the README
</commit_message>
<xml_diff>
--- a/docs/submission/DATAQUEST_3.0_Rivet.pptx
+++ b/docs/submission/DATAQUEST_3.0_Rivet.pptx
@@ -345,7 +345,7 @@
           <a:p>
             <a:fld id="{5BCAD085-E8A6-8845-BD4E-CB4CCA059FC4}" type="datetimeFigureOut">
               <a:rPr lang="en-US" smtClean="0"/>
-              <a:t>10/7/2026</a:t>
+              <a:t>10/8/2026</a:t>
             </a:fld>
             <a:endParaRPr lang="en-US"/>
           </a:p>
@@ -513,7 +513,7 @@
           <a:p>
             <a:fld id="{5BCAD085-E8A6-8845-BD4E-CB4CCA059FC4}" type="datetimeFigureOut">
               <a:rPr lang="en-US" smtClean="0"/>
-              <a:t>10/7/2026</a:t>
+              <a:t>10/8/2026</a:t>
             </a:fld>
             <a:endParaRPr lang="en-US"/>
           </a:p>
@@ -691,7 +691,7 @@
           <a:p>
             <a:fld id="{5BCAD085-E8A6-8845-BD4E-CB4CCA059FC4}" type="datetimeFigureOut">
               <a:rPr lang="en-US" smtClean="0"/>
-              <a:t>10/7/2026</a:t>
+              <a:t>10/8/2026</a:t>
             </a:fld>
             <a:endParaRPr lang="en-US"/>
           </a:p>
@@ -859,7 +859,7 @@
           <a:p>
             <a:fld id="{5BCAD085-E8A6-8845-BD4E-CB4CCA059FC4}" type="datetimeFigureOut">
               <a:rPr lang="en-US" smtClean="0"/>
-              <a:t>10/7/2026</a:t>
+              <a:t>10/8/2026</a:t>
             </a:fld>
             <a:endParaRPr lang="en-US"/>
           </a:p>
@@ -1104,7 +1104,7 @@
           <a:p>
             <a:fld id="{5BCAD085-E8A6-8845-BD4E-CB4CCA059FC4}" type="datetimeFigureOut">
               <a:rPr lang="en-US" smtClean="0"/>
-              <a:t>10/7/2026</a:t>
+              <a:t>10/8/2026</a:t>
             </a:fld>
             <a:endParaRPr lang="en-US"/>
           </a:p>
@@ -1389,7 +1389,7 @@
           <a:p>
             <a:fld id="{5BCAD085-E8A6-8845-BD4E-CB4CCA059FC4}" type="datetimeFigureOut">
               <a:rPr lang="en-US" smtClean="0"/>
-              <a:t>10/7/2026</a:t>
+              <a:t>10/8/2026</a:t>
             </a:fld>
             <a:endParaRPr lang="en-US"/>
           </a:p>
@@ -1808,7 +1808,7 @@
           <a:p>
             <a:fld id="{5BCAD085-E8A6-8845-BD4E-CB4CCA059FC4}" type="datetimeFigureOut">
               <a:rPr lang="en-US" smtClean="0"/>
-              <a:t>10/7/2026</a:t>
+              <a:t>10/8/2026</a:t>
             </a:fld>
             <a:endParaRPr lang="en-US"/>
           </a:p>
@@ -1925,7 +1925,7 @@
           <a:p>
             <a:fld id="{5BCAD085-E8A6-8845-BD4E-CB4CCA059FC4}" type="datetimeFigureOut">
               <a:rPr lang="en-US" smtClean="0"/>
-              <a:t>10/7/2026</a:t>
+              <a:t>10/8/2026</a:t>
             </a:fld>
             <a:endParaRPr lang="en-US"/>
           </a:p>
@@ -2020,7 +2020,7 @@
           <a:p>
             <a:fld id="{5BCAD085-E8A6-8845-BD4E-CB4CCA059FC4}" type="datetimeFigureOut">
               <a:rPr lang="en-US" smtClean="0"/>
-              <a:t>10/7/2026</a:t>
+              <a:t>10/8/2026</a:t>
             </a:fld>
             <a:endParaRPr lang="en-US"/>
           </a:p>
@@ -2295,7 +2295,7 @@
           <a:p>
             <a:fld id="{5BCAD085-E8A6-8845-BD4E-CB4CCA059FC4}" type="datetimeFigureOut">
               <a:rPr lang="en-US" smtClean="0"/>
-              <a:t>10/7/2026</a:t>
+              <a:t>10/8/2026</a:t>
             </a:fld>
             <a:endParaRPr lang="en-US"/>
           </a:p>
@@ -2547,7 +2547,7 @@
           <a:p>
             <a:fld id="{5BCAD085-E8A6-8845-BD4E-CB4CCA059FC4}" type="datetimeFigureOut">
               <a:rPr lang="en-US" smtClean="0"/>
-              <a:t>10/7/2026</a:t>
+              <a:t>10/8/2026</a:t>
             </a:fld>
             <a:endParaRPr lang="en-US"/>
           </a:p>
@@ -2758,7 +2758,7 @@
           <a:p>
             <a:fld id="{5BCAD085-E8A6-8845-BD4E-CB4CCA059FC4}" type="datetimeFigureOut">
               <a:rPr lang="en-US" smtClean="0"/>
-              <a:t>10/7/2026</a:t>
+              <a:t>10/8/2026</a:t>
             </a:fld>
             <a:endParaRPr lang="en-US"/>
           </a:p>
@@ -4503,7 +4503,7 @@
         <p:spPr>
           <a:xfrm>
             <a:off x="1920240" y="3520440"/>
-            <a:ext cx="4023360" cy="2300986"/>
+            <a:ext cx="4023360" cy="1987724"/>
           </a:xfrm>
           <a:prstGeom prst="rect">
             <a:avLst/>
@@ -4665,8 +4665,25 @@
                 <a:ea typeface="Mulish"/>
                 <a:cs typeface="Mulish"/>
               </a:rPr>
-              <a:t>[ Your track ]</a:t>
-            </a:r>
+              <a:t> </a:t>
+            </a:r>
+            <a:r>
+              <a:rPr lang="en-IN" sz="1050" b="1" cap="all" dirty="0">
+                <a:solidFill>
+                  <a:srgbClr val="079ED2"/>
+                </a:solidFill>
+                <a:latin typeface="Mulish"/>
+              </a:rPr>
+              <a:t>DQBH</a:t>
+            </a:r>
+            <a:endParaRPr lang="en-US" sz="1050" b="1" dirty="0">
+              <a:solidFill>
+                <a:srgbClr val="079ED2"/>
+              </a:solidFill>
+              <a:latin typeface="Mulish"/>
+              <a:ea typeface="Mulish"/>
+              <a:cs typeface="Mulish"/>
+            </a:endParaRPr>
           </a:p>
         </p:txBody>
       </p:sp>

</xml_diff>